<commit_message>
Apresentação  de trabalhoa atualizado
</commit_message>
<xml_diff>
--- a/Apresentacao_Final.pptx
+++ b/Apresentacao_Final.pptx
@@ -2790,7 +2790,7 @@
         <p:spPr>
           <a:xfrm>
             <a:off x="960120" y="4892040"/>
-            <a:ext cx="5623560" cy="914400"/>
+            <a:ext cx="5641848" cy="1161288"/>
           </a:xfrm>
           <a:prstGeom prst="roundRect">
             <a:avLst/>
@@ -7830,8 +7830,8 @@
         </p:nvSpPr>
         <p:spPr>
           <a:xfrm>
-            <a:off x="777240" y="4965192"/>
-            <a:ext cx="5074920" cy="685800"/>
+            <a:off x="777240" y="4973007"/>
+            <a:ext cx="5138928" cy="896112"/>
           </a:xfrm>
           <a:prstGeom prst="roundRect">
             <a:avLst/>

</xml_diff>